<commit_message>
Fix factual counts in Level 3 PPT
- 22 test functions in test_level3.py (was 30)
- package is 2619 lines (was ~2200)
- outputs are 26 files: 8 CSV, 12 PNG, 4 JSON, 1 MD, 1 YAML (was 24/CSV*5/JSON*3)
</commit_message>
<xml_diff>
--- a/Level3_三维AOD长距离运输与柱面透镜_总结报告.pptx
+++ b/Level3_三维AOD长距离运输与柱面透镜_总结报告.pptx
@@ -3300,7 +3300,7 @@
                   <a:srgbClr val="88A8C8"/>
                 </a:solidFill>
               </a:rPr>
-              <a:t>preflight 16 项全通过 · 96 个粗扫描格点 · 30 项 Level 3 测试</a:t>
+              <a:t>preflight 16 项全通过 · 96 个粗扫描格点 · 22 项 Level 3 测试</a:t>
             </a:r>
           </a:p>
         </p:txBody>
@@ -5664,7 +5664,7 @@
                   <a:srgbClr val="DDE8F5"/>
                 </a:solidFill>
               </a:rPr>
-              <a:t>simulation/level2_joint_transfer/src/level3_3d_transport_lensing/，约 2200 行</a:t>
+              <a:t>simulation/level2_joint_transfer/src/level3_3d_transport_lensing/，共 2619 行</a:t>
             </a:r>
           </a:p>
         </p:txBody>
@@ -6020,7 +6020,7 @@
                   <a:srgbClr val="666666"/>
                 </a:solidFill>
               </a:rPr>
-              <a:t>　test_level3.py 共 30 项，覆盖任务书 25 项要求：势/力/轨迹/采样/功-能/判据/种子隔离/CLI 冒烟/JSON 严格性/sources 保护</a:t>
+              <a:t>　test_level3.py 共 22 项测试函数，覆盖任务书 25 项要求：势/力/轨迹/采样/功-能/判据/种子隔离/CLI 冒烟/JSON 严格性/sources 保护</a:t>
             </a:r>
           </a:p>
           <a:p>
@@ -6043,7 +6043,7 @@
                   <a:srgbClr val="666666"/>
                 </a:solidFill>
               </a:rPr>
-              <a:t>　24 个文件：CSV×5、JSON×3、Markdown、PNG×12、config_used.yaml，全部程序化复检 schema 与有限值；支持事后合并视觉审阅（--apply-visual-review）</a:t>
+              <a:t>　26 个文件：CSV×8、PNG×12、JSON×4、Markdown×1、YAML×1，全部程序化复检 schema 与有限值；支持事后合并视觉审阅（--apply-visual-review）</a:t>
             </a:r>
           </a:p>
         </p:txBody>

</xml_diff>